<commit_message>
Update Final Presentation Skeleton
</commit_message>
<xml_diff>
--- a/reports/Final_Presentation_Skeleton.pptx
+++ b/reports/Final_Presentation_Skeleton.pptx
@@ -7748,24 +7748,15 @@
           </a:bodyPr>
           <a:lstStyle/>
           <a:p>
-            <a:pPr algn="l"/>
-            <a:r>
-              <a:rPr sz="2200" b="1" dirty="0">
+            <a:pPr marL="0" algn="l" defTabSz="457200" rtl="0" eaLnBrk="1" latinLnBrk="0" hangingPunct="1"/>
+            <a:r>
+              <a:rPr lang="en-US" sz="2200" b="1" dirty="0">
                 <a:solidFill>
                   <a:srgbClr val="A8615A"/>
                 </a:solidFill>
                 <a:latin typeface="Georgia"/>
               </a:rPr>
-              <a:t>~</a:t>
-            </a:r>
-            <a:r>
-              <a:rPr lang="he-IL" sz="2200" b="1" dirty="0">
-                <a:solidFill>
-                  <a:srgbClr val="A8615A"/>
-                </a:solidFill>
-                <a:latin typeface="Georgia"/>
-              </a:rPr>
-              <a:t>10,000</a:t>
+              <a:t>10,039 =&gt; 9,794</a:t>
             </a:r>
             <a:endParaRPr sz="2200" b="1" dirty="0">
               <a:solidFill>
@@ -7864,7 +7855,7 @@
         <p:spPr>
           <a:xfrm>
             <a:off x="1005840" y="2834640"/>
-            <a:ext cx="3657600" cy="457200"/>
+            <a:ext cx="3657600" cy="430887"/>
           </a:xfrm>
           <a:prstGeom prst="rect">
             <a:avLst/>
@@ -7879,14 +7870,20 @@
           <a:p>
             <a:pPr algn="l"/>
             <a:r>
-              <a:rPr sz="2200" b="1">
+              <a:rPr lang="en-US" sz="2200" b="1" dirty="0">
                 <a:solidFill>
                   <a:srgbClr val="A8615A"/>
                 </a:solidFill>
                 <a:latin typeface="Georgia"/>
               </a:rPr>
-              <a:t>5 sessions</a:t>
-            </a:r>
+              <a:t>Merge happy + excited</a:t>
+            </a:r>
+            <a:endParaRPr sz="2200" b="1" dirty="0">
+              <a:solidFill>
+                <a:srgbClr val="A8615A"/>
+              </a:solidFill>
+              <a:latin typeface="Georgia"/>
+            </a:endParaRPr>
           </a:p>
         </p:txBody>
       </p:sp>
@@ -7899,29 +7896,30 @@
         <p:spPr>
           <a:xfrm>
             <a:off x="1005840" y="3200400"/>
-            <a:ext cx="4114800" cy="228600"/>
-          </a:xfrm>
-          <a:prstGeom prst="rect">
-            <a:avLst/>
-          </a:prstGeom>
-          <a:noFill/>
-        </p:spPr>
-        <p:txBody>
-          <a:bodyPr wrap="square">
-            <a:spAutoFit/>
-          </a:bodyPr>
-          <a:lstStyle/>
-          <a:p>
-            <a:pPr algn="l"/>
-            <a:r>
-              <a:rPr sz="1100" b="0">
-                <a:solidFill>
-                  <a:srgbClr val="2E3440"/>
-                </a:solidFill>
-                <a:latin typeface="Calibri"/>
-              </a:rPr>
-              <a:t>Unique speaker pairs (LOSO folds)</a:t>
-            </a:r>
+            <a:ext cx="4543412" cy="261610"/>
+          </a:xfrm>
+          <a:prstGeom prst="rect">
+            <a:avLst/>
+          </a:prstGeom>
+          <a:noFill/>
+        </p:spPr>
+        <p:txBody>
+          <a:bodyPr wrap="square">
+            <a:spAutoFit/>
+          </a:bodyPr>
+          <a:lstStyle/>
+          <a:p>
+            <a:pPr marL="0" algn="l" defTabSz="457200" rtl="0" eaLnBrk="1" latinLnBrk="0" hangingPunct="1"/>
+            <a:r>
+              <a:rPr lang="en-US" sz="1100" dirty="0"/>
+              <a:t>They are acoustically identical, and human taggers got them confused.</a:t>
+            </a:r>
+            <a:endParaRPr sz="1100" b="0" dirty="0">
+              <a:solidFill>
+                <a:srgbClr val="2E3440"/>
+              </a:solidFill>
+              <a:latin typeface="Calibri"/>
+            </a:endParaRPr>
           </a:p>
         </p:txBody>
       </p:sp>
@@ -7977,8 +7975,8 @@
         </p:nvSpPr>
         <p:spPr>
           <a:xfrm>
-            <a:off x="1005840" y="3703320"/>
-            <a:ext cx="3657600" cy="457200"/>
+            <a:off x="1005840" y="3579764"/>
+            <a:ext cx="3657600" cy="430887"/>
           </a:xfrm>
           <a:prstGeom prst="rect">
             <a:avLst/>
@@ -7993,14 +7991,20 @@
           <a:p>
             <a:pPr algn="l"/>
             <a:r>
-              <a:rPr sz="2200" b="1">
+              <a:rPr lang="en-US" sz="2200" b="1" dirty="0">
                 <a:solidFill>
                   <a:srgbClr val="A8615A"/>
                 </a:solidFill>
                 <a:latin typeface="Georgia"/>
               </a:rPr>
-              <a:t>10 actors</a:t>
-            </a:r>
+              <a:t>Frustrated</a:t>
+            </a:r>
+            <a:endParaRPr sz="2200" b="1" dirty="0">
+              <a:solidFill>
+                <a:srgbClr val="A8615A"/>
+              </a:solidFill>
+              <a:latin typeface="Georgia"/>
+            </a:endParaRPr>
           </a:p>
         </p:txBody>
       </p:sp>
@@ -8012,8 +8016,8 @@
         </p:nvSpPr>
         <p:spPr>
           <a:xfrm>
-            <a:off x="1005840" y="4069080"/>
-            <a:ext cx="4114800" cy="228600"/>
+            <a:off x="1005840" y="3912513"/>
+            <a:ext cx="4114800" cy="430887"/>
           </a:xfrm>
           <a:prstGeom prst="rect">
             <a:avLst/>
@@ -8028,14 +8032,15 @@
           <a:p>
             <a:pPr algn="l"/>
             <a:r>
-              <a:rPr sz="1100" b="0">
-                <a:solidFill>
-                  <a:srgbClr val="2E3440"/>
-                </a:solidFill>
-                <a:latin typeface="Calibri"/>
-              </a:rPr>
-              <a:t>5 male · 5 female</a:t>
-            </a:r>
+              <a:rPr lang="en-US" sz="1100" dirty="0"/>
+              <a:t>Confusing but makes up about 30% of the data and couldn't be thrown away.</a:t>
+            </a:r>
+            <a:endParaRPr sz="1100" b="0" dirty="0">
+              <a:solidFill>
+                <a:srgbClr val="2E3440"/>
+              </a:solidFill>
+              <a:latin typeface="Calibri"/>
+            </a:endParaRPr>
           </a:p>
         </p:txBody>
       </p:sp>
@@ -8091,8 +8096,8 @@
         </p:nvSpPr>
         <p:spPr>
           <a:xfrm>
-            <a:off x="1005840" y="4572000"/>
-            <a:ext cx="3657600" cy="457200"/>
+            <a:off x="960120" y="4428589"/>
+            <a:ext cx="3657600" cy="430887"/>
           </a:xfrm>
           <a:prstGeom prst="rect">
             <a:avLst/>
@@ -8107,14 +8112,20 @@
           <a:p>
             <a:pPr algn="l"/>
             <a:r>
-              <a:rPr sz="2200" b="1">
+              <a:rPr lang="en-US" sz="2200" b="1" dirty="0">
                 <a:solidFill>
                   <a:srgbClr val="A8615A"/>
                 </a:solidFill>
                 <a:latin typeface="Georgia"/>
               </a:rPr>
-              <a:t>~12 h</a:t>
-            </a:r>
+              <a:t>UAR</a:t>
+            </a:r>
+            <a:endParaRPr sz="2200" b="1" dirty="0">
+              <a:solidFill>
+                <a:srgbClr val="A8615A"/>
+              </a:solidFill>
+              <a:latin typeface="Georgia"/>
+            </a:endParaRPr>
           </a:p>
         </p:txBody>
       </p:sp>
@@ -8126,8 +8137,8 @@
         </p:nvSpPr>
         <p:spPr>
           <a:xfrm>
-            <a:off x="1005840" y="4937760"/>
-            <a:ext cx="4114800" cy="228600"/>
+            <a:off x="1005840" y="4753482"/>
+            <a:ext cx="4114800" cy="430887"/>
           </a:xfrm>
           <a:prstGeom prst="rect">
             <a:avLst/>
@@ -8142,14 +8153,23 @@
           <a:p>
             <a:pPr algn="l"/>
             <a:r>
-              <a:rPr sz="1100" b="0">
-                <a:solidFill>
-                  <a:srgbClr val="2E3440"/>
-                </a:solidFill>
-                <a:latin typeface="Calibri"/>
-              </a:rPr>
-              <a:t>Total audio · 16 kHz mono WAV</a:t>
-            </a:r>
+              <a:rPr lang="en-US" sz="1100" dirty="0"/>
+              <a:t>There is a built-in imbalance </a:t>
+            </a:r>
+            <a:r>
+              <a:rPr lang="he-IL" sz="1100" dirty="0"/>
+              <a:t>)</a:t>
+            </a:r>
+            <a:r>
+              <a:rPr lang="en-US" sz="1100" dirty="0"/>
+              <a:t>ratio of 2.33), so our important metric going forward will be UAR (Unweighted Average Recall)</a:t>
+            </a:r>
+            <a:endParaRPr sz="1100" b="0" dirty="0">
+              <a:solidFill>
+                <a:srgbClr val="2E3440"/>
+              </a:solidFill>
+              <a:latin typeface="Calibri"/>
+            </a:endParaRPr>
           </a:p>
         </p:txBody>
       </p:sp>
@@ -8225,10 +8245,10 @@
       </p:sp>
       <p:pic>
         <p:nvPicPr>
-          <p:cNvPr id="27" name="Picture 26">
+          <p:cNvPr id="28" name="Picture 27">
             <a:extLst>
               <a:ext uri="{FF2B5EF4-FFF2-40B4-BE49-F238E27FC236}">
-                <a16:creationId xmlns:a16="http://schemas.microsoft.com/office/drawing/2014/main" id="{C5346154-EFB6-C9AB-C4C1-282945238927}"/>
+                <a16:creationId xmlns:a16="http://schemas.microsoft.com/office/drawing/2014/main" id="{ECAAD43E-9BCF-D97A-C9E8-95FF281586C0}"/>
               </a:ext>
             </a:extLst>
           </p:cNvPr>
@@ -8245,8 +8265,8 @@
         </p:blipFill>
         <p:spPr>
           <a:xfrm>
-            <a:off x="5549252" y="1878173"/>
-            <a:ext cx="6200788" cy="3361340"/>
+            <a:off x="5481866" y="2368554"/>
+            <a:ext cx="6268174" cy="2112006"/>
           </a:xfrm>
           <a:prstGeom prst="rect">
             <a:avLst/>
@@ -8317,7 +8337,7 @@
           <a:bodyPr rtlCol="0" anchor="ctr"/>
           <a:lstStyle/>
           <a:p>
-            <a:pPr algn="ctr"/>
+            <a:pPr marL="0" algn="ctr" defTabSz="457200" rtl="1" eaLnBrk="1" latinLnBrk="0" hangingPunct="1"/>
             <a:endParaRPr/>
           </a:p>
         </p:txBody>
@@ -8425,7 +8445,7 @@
           <a:p>
             <a:pPr algn="l"/>
             <a:r>
-              <a:rPr sz="2800" b="1">
+              <a:rPr sz="2800" b="1" dirty="0">
                 <a:solidFill>
                   <a:srgbClr val="4C566A"/>
                 </a:solidFill>
@@ -8539,7 +8559,7 @@
           <a:p>
             <a:pPr algn="l"/>
             <a:r>
-              <a:rPr sz="1000" b="1">
+              <a:rPr sz="1000" b="1" dirty="0">
                 <a:solidFill>
                   <a:srgbClr val="A8615A"/>
                 </a:solidFill>
@@ -8624,7 +8644,7 @@
           <a:bodyPr rtlCol="0" anchor="ctr"/>
           <a:lstStyle/>
           <a:p>
-            <a:pPr algn="ctr"/>
+            <a:pPr marL="0" algn="ctr" defTabSz="457200" rtl="1" eaLnBrk="1" latinLnBrk="0" hangingPunct="1"/>
             <a:endParaRPr/>
           </a:p>
         </p:txBody>
@@ -8638,7 +8658,7 @@
         <p:spPr>
           <a:xfrm>
             <a:off x="868680" y="2670048"/>
-            <a:ext cx="1828800" cy="457200"/>
+            <a:ext cx="1828800" cy="246221"/>
           </a:xfrm>
           <a:prstGeom prst="rect">
             <a:avLst/>
@@ -8653,14 +8673,20 @@
           <a:p>
             <a:pPr algn="l"/>
             <a:r>
-              <a:rPr sz="1000" b="1">
+              <a:rPr lang="en-US" sz="1000" b="1" dirty="0">
                 <a:solidFill>
                   <a:srgbClr val="A8615A"/>
                 </a:solidFill>
                 <a:latin typeface="Calibri"/>
               </a:rPr>
-              <a:t>Audio Clipping</a:t>
-            </a:r>
+              <a:t>Audio Preprocessing</a:t>
+            </a:r>
+            <a:endParaRPr sz="1000" b="1" dirty="0">
+              <a:solidFill>
+                <a:srgbClr val="A8615A"/>
+              </a:solidFill>
+              <a:latin typeface="Calibri"/>
+            </a:endParaRPr>
           </a:p>
         </p:txBody>
       </p:sp>
@@ -8673,29 +8699,36 @@
         <p:spPr>
           <a:xfrm>
             <a:off x="2926080" y="2670048"/>
-            <a:ext cx="8686800" cy="502920"/>
-          </a:xfrm>
-          <a:prstGeom prst="rect">
-            <a:avLst/>
-          </a:prstGeom>
-          <a:noFill/>
-        </p:spPr>
-        <p:txBody>
-          <a:bodyPr wrap="square">
-            <a:spAutoFit/>
-          </a:bodyPr>
-          <a:lstStyle/>
-          <a:p>
-            <a:pPr algn="l"/>
-            <a:r>
-              <a:rPr sz="1000" b="0">
-                <a:solidFill>
-                  <a:srgbClr val="2E3440"/>
-                </a:solidFill>
-                <a:latin typeface="Calibri"/>
-              </a:rPr>
-              <a:t>Removed recordings shorter than 0.3 s (noise fragments).</a:t>
-            </a:r>
+            <a:ext cx="8686800" cy="246221"/>
+          </a:xfrm>
+          <a:prstGeom prst="rect">
+            <a:avLst/>
+          </a:prstGeom>
+          <a:noFill/>
+        </p:spPr>
+        <p:txBody>
+          <a:bodyPr wrap="square">
+            <a:spAutoFit/>
+          </a:bodyPr>
+          <a:lstStyle/>
+          <a:p>
+            <a:pPr marL="0" algn="l" defTabSz="457200" eaLnBrk="1" latinLnBrk="0" hangingPunct="1"/>
+            <a:r>
+              <a:rPr lang="en-US" sz="1000" b="0" i="0" u="none" strike="noStrike" dirty="0">
+                <a:solidFill>
+                  <a:srgbClr val="000000"/>
+                </a:solidFill>
+                <a:effectLst/>
+                <a:latin typeface="-webkit-standard"/>
+              </a:rPr>
+              <a:t>Applied amplitude normalization and signal padding/trimming to ensure uniform utterance lengths</a:t>
+            </a:r>
+            <a:endParaRPr sz="1000" b="0" dirty="0">
+              <a:solidFill>
+                <a:srgbClr val="2E3440"/>
+              </a:solidFill>
+              <a:latin typeface="Calibri"/>
+            </a:endParaRPr>
           </a:p>
         </p:txBody>
       </p:sp>
@@ -8767,7 +8800,7 @@
           <a:p>
             <a:pPr algn="l"/>
             <a:r>
-              <a:rPr sz="1000" b="1">
+              <a:rPr sz="1000" b="1" dirty="0">
                 <a:solidFill>
                   <a:srgbClr val="A8615A"/>
                 </a:solidFill>
@@ -8787,29 +8820,62 @@
         <p:spPr>
           <a:xfrm>
             <a:off x="2926080" y="3374136"/>
-            <a:ext cx="8686800" cy="502920"/>
-          </a:xfrm>
-          <a:prstGeom prst="rect">
-            <a:avLst/>
-          </a:prstGeom>
-          <a:noFill/>
-        </p:spPr>
-        <p:txBody>
-          <a:bodyPr wrap="square">
-            <a:spAutoFit/>
-          </a:bodyPr>
-          <a:lstStyle/>
+            <a:ext cx="8686800" cy="400110"/>
+          </a:xfrm>
+          <a:prstGeom prst="rect">
+            <a:avLst/>
+          </a:prstGeom>
+          <a:noFill/>
+        </p:spPr>
+        <p:txBody>
+          <a:bodyPr wrap="square">
+            <a:spAutoFit/>
+          </a:bodyPr>
+          <a:lstStyle/>
+          <a:p>
+            <a:pPr>
+              <a:buNone/>
+            </a:pPr>
+            <a:r>
+              <a:rPr sz="1000" b="0" dirty="0">
+                <a:solidFill>
+                  <a:srgbClr val="2E3440"/>
+                </a:solidFill>
+                <a:latin typeface="Calibri"/>
+              </a:rPr>
+              <a:t>34 acoustic features per clip: 13 MFCCs × 2 (</a:t>
+            </a:r>
+            <a:r>
+              <a:rPr sz="1000" b="0" dirty="0" err="1">
+                <a:solidFill>
+                  <a:srgbClr val="2E3440"/>
+                </a:solidFill>
+                <a:latin typeface="Calibri"/>
+              </a:rPr>
+              <a:t>mean+std</a:t>
+            </a:r>
+            <a:r>
+              <a:rPr sz="1000" b="0" dirty="0">
+                <a:solidFill>
+                  <a:srgbClr val="2E3440"/>
+                </a:solidFill>
+                <a:latin typeface="Calibri"/>
+              </a:rPr>
+              <a:t>), Pitch, RMS, </a:t>
+            </a:r>
+            <a:r>
+              <a:rPr lang="en-US" sz="1000" dirty="0"/>
+              <a:t>Zero Crossing Rate (ZCR), and Spectral Centroid to capture time-frequency dynamics.</a:t>
+            </a:r>
+          </a:p>
           <a:p>
             <a:pPr algn="l"/>
-            <a:r>
-              <a:rPr sz="1000" b="0">
-                <a:solidFill>
-                  <a:srgbClr val="2E3440"/>
-                </a:solidFill>
-                <a:latin typeface="Calibri"/>
-              </a:rPr>
-              <a:t>34 acoustic features per clip: 13 MFCCs × 2 (mean+std), Pitch, RMS, Spectral Centroid, ZCR.</a:t>
-            </a:r>
+            <a:endParaRPr sz="1000" b="0" dirty="0">
+              <a:solidFill>
+                <a:srgbClr val="2E3440"/>
+              </a:solidFill>
+              <a:latin typeface="Calibri"/>
+            </a:endParaRPr>
           </a:p>
         </p:txBody>
       </p:sp>
@@ -9289,7 +9355,7 @@
           <a:bodyPr rtlCol="0" anchor="ctr"/>
           <a:lstStyle/>
           <a:p>
-            <a:pPr algn="ctr"/>
+            <a:pPr marL="0" algn="ctr" defTabSz="457200" rtl="1" eaLnBrk="1" latinLnBrk="0" hangingPunct="1"/>
             <a:endParaRPr/>
           </a:p>
         </p:txBody>
@@ -9445,41 +9511,6 @@
       </p:sp>
       <p:sp>
         <p:nvSpPr>
-          <p:cNvPr id="7" name="TextBox 6"/>
-          <p:cNvSpPr txBox="1"/>
-          <p:nvPr/>
-        </p:nvSpPr>
-        <p:spPr>
-          <a:xfrm>
-            <a:off x="777240" y="1874519"/>
-            <a:ext cx="10515600" cy="3108960"/>
-          </a:xfrm>
-          <a:prstGeom prst="rect">
-            <a:avLst/>
-          </a:prstGeom>
-          <a:noFill/>
-        </p:spPr>
-        <p:txBody>
-          <a:bodyPr wrap="square">
-            <a:spAutoFit/>
-          </a:bodyPr>
-          <a:lstStyle/>
-          <a:p>
-            <a:pPr algn="ctr"/>
-            <a:r>
-              <a:rPr sz="1300" b="0" dirty="0">
-                <a:solidFill>
-                  <a:srgbClr val="BBBBBB"/>
-                </a:solidFill>
-                <a:latin typeface="Calibri"/>
-              </a:rPr>
-              <a:t>[INSERT: class distribution bar chart + feature KDE plots]</a:t>
-            </a:r>
-          </a:p>
-        </p:txBody>
-      </p:sp>
-      <p:sp>
-        <p:nvSpPr>
           <p:cNvPr id="8" name="Rectangle 7"/>
           <p:cNvSpPr/>
           <p:nvPr/>
@@ -9517,21 +9548,21 @@
           <a:bodyPr rtlCol="0" anchor="ctr"/>
           <a:lstStyle/>
           <a:p>
-            <a:pPr algn="ctr"/>
+            <a:pPr marL="0" algn="ctr" defTabSz="457200" rtl="1" eaLnBrk="1" latinLnBrk="0" hangingPunct="1"/>
             <a:endParaRPr/>
           </a:p>
         </p:txBody>
       </p:sp>
       <p:sp>
         <p:nvSpPr>
-          <p:cNvPr id="9" name="TextBox 8"/>
-          <p:cNvSpPr txBox="1"/>
-          <p:nvPr/>
-        </p:nvSpPr>
-        <p:spPr>
-          <a:xfrm>
-            <a:off x="594360" y="5166360"/>
-            <a:ext cx="2743200" cy="228600"/>
+          <p:cNvPr id="10" name="TextBox 9"/>
+          <p:cNvSpPr txBox="1"/>
+          <p:nvPr/>
+        </p:nvSpPr>
+        <p:spPr>
+          <a:xfrm>
+            <a:off x="621792" y="5234600"/>
+            <a:ext cx="10972800" cy="1015663"/>
           </a:xfrm>
           <a:prstGeom prst="rect">
             <a:avLst/>
@@ -9546,52 +9577,138 @@
           <a:p>
             <a:pPr algn="l"/>
             <a:r>
-              <a:rPr sz="1000" b="1">
-                <a:solidFill>
-                  <a:srgbClr val="A8615A"/>
-                </a:solidFill>
-                <a:latin typeface="Calibri"/>
-              </a:rPr>
-              <a:t>KEY FINDINGS</a:t>
-            </a:r>
-          </a:p>
-        </p:txBody>
-      </p:sp>
-      <p:sp>
-        <p:nvSpPr>
-          <p:cNvPr id="10" name="TextBox 9"/>
-          <p:cNvSpPr txBox="1"/>
-          <p:nvPr/>
-        </p:nvSpPr>
-        <p:spPr>
-          <a:xfrm>
-            <a:off x="594360" y="5413248"/>
-            <a:ext cx="10972800" cy="914400"/>
-          </a:xfrm>
-          <a:prstGeom prst="rect">
-            <a:avLst/>
-          </a:prstGeom>
-          <a:noFill/>
-        </p:spPr>
-        <p:txBody>
-          <a:bodyPr wrap="square">
-            <a:spAutoFit/>
-          </a:bodyPr>
-          <a:lstStyle/>
-          <a:p>
-            <a:pPr algn="l"/>
-            <a:r>
-              <a:rPr sz="950" b="0">
-                <a:solidFill>
-                  <a:srgbClr val="2E3440"/>
-                </a:solidFill>
-                <a:latin typeface="Calibri"/>
+              <a:rPr sz="1200" dirty="0">
+                <a:solidFill>
+                  <a:srgbClr val="000000"/>
+                </a:solidFill>
+                <a:latin typeface="-webkit-standard"/>
               </a:rPr>
               <a:t>•  Angry has highest pitch (mean ~208 Hz), loudness (RMS) and ZCR — clear acoustic signature.
 •  Sad is the quietest and slowest; pitch stays in 100–150 Hz range with minimal variance.
-•  Imbalance ratio ~2× (happy vs sad) — UAR is the principled metric, not accuracy.
-•  No missing values across all 34 features.</a:t>
-            </a:r>
+•  </a:t>
+            </a:r>
+            <a:r>
+              <a:rPr lang="en-US" sz="1200" dirty="0">
+                <a:solidFill>
+                  <a:srgbClr val="000000"/>
+                </a:solidFill>
+                <a:latin typeface="-webkit-standard"/>
+              </a:rPr>
+              <a:t>Audio Analysis: Acoustic features effectively capture emotional arousal, contrasting </a:t>
+            </a:r>
+            <a:r>
+              <a:rPr lang="en-US" sz="1200" b="0" i="0" u="none" strike="noStrike" dirty="0">
+                <a:solidFill>
+                  <a:srgbClr val="000000"/>
+                </a:solidFill>
+                <a:effectLst/>
+                <a:latin typeface="-webkit-standard"/>
+              </a:rPr>
+              <a:t>the sharp, high-energy bursts of anger with the flat, quiet profile of sadness.</a:t>
+            </a:r>
+            <a:r>
+              <a:rPr sz="1200" b="0" dirty="0">
+                <a:solidFill>
+                  <a:srgbClr val="2E3440"/>
+                </a:solidFill>
+                <a:latin typeface="Calibri"/>
+              </a:rPr>
+              <a:t>
+•  </a:t>
+            </a:r>
+            <a:r>
+              <a:rPr lang="en-US" sz="1200" b="1" i="0" dirty="0">
+                <a:solidFill>
+                  <a:srgbClr val="000000"/>
+                </a:solidFill>
+                <a:effectLst/>
+              </a:rPr>
+              <a:t>Text Analysis:</a:t>
+            </a:r>
+            <a:r>
+              <a:rPr lang="en-US" sz="1200" b="0" i="0" u="none" strike="noStrike" dirty="0">
+                <a:solidFill>
+                  <a:srgbClr val="000000"/>
+                </a:solidFill>
+                <a:effectLst/>
+                <a:latin typeface="-webkit-standard"/>
+              </a:rPr>
+              <a:t> The near-identical vocabulary across all emotions proves that simple word counts are insufficient</a:t>
+            </a:r>
+            <a:endParaRPr lang="he-IL" sz="1200" b="0" i="0" u="none" strike="noStrike" dirty="0">
+              <a:solidFill>
+                <a:srgbClr val="000000"/>
+              </a:solidFill>
+              <a:effectLst/>
+              <a:latin typeface="-webkit-standard"/>
+            </a:endParaRPr>
+          </a:p>
+          <a:p>
+            <a:pPr algn="l"/>
+            <a:r>
+              <a:rPr lang="en-US" sz="1200" b="0" dirty="0">
+                <a:solidFill>
+                  <a:srgbClr val="2E3440"/>
+                </a:solidFill>
+                <a:latin typeface="Calibri"/>
+              </a:rPr>
+              <a:t>•</a:t>
+            </a:r>
+            <a:r>
+              <a:rPr lang="he-IL" sz="1200" dirty="0">
+                <a:solidFill>
+                  <a:srgbClr val="000000"/>
+                </a:solidFill>
+                <a:latin typeface="-webkit-standard"/>
+              </a:rPr>
+              <a:t> </a:t>
+            </a:r>
+            <a:r>
+              <a:rPr lang="en-US" sz="1200" b="0" i="0" u="none" strike="noStrike" dirty="0">
+                <a:solidFill>
+                  <a:srgbClr val="000000"/>
+                </a:solidFill>
+                <a:effectLst/>
+                <a:latin typeface="-webkit-standard"/>
+              </a:rPr>
+              <a:t>highlighting the need for deep contextual models and </a:t>
+            </a:r>
+            <a:r>
+              <a:rPr lang="he-IL" sz="1200" b="0" i="0" u="none" strike="noStrike" dirty="0">
+                <a:solidFill>
+                  <a:srgbClr val="000000"/>
+                </a:solidFill>
+                <a:effectLst/>
+                <a:latin typeface="-webkit-standard"/>
+              </a:rPr>
+              <a:t> </a:t>
+            </a:r>
+            <a:r>
+              <a:rPr lang="en-US" sz="1200" b="0" i="0" u="none" strike="noStrike" dirty="0">
+                <a:solidFill>
+                  <a:srgbClr val="000000"/>
+                </a:solidFill>
+                <a:effectLst/>
+                <a:latin typeface="-webkit-standard"/>
+              </a:rPr>
+              <a:t>multimodal fusion</a:t>
+            </a:r>
+            <a:r>
+              <a:rPr lang="en-US" sz="1000" b="0" i="0" u="none" strike="noStrike" dirty="0">
+                <a:solidFill>
+                  <a:srgbClr val="000000"/>
+                </a:solidFill>
+                <a:effectLst/>
+                <a:latin typeface="-webkit-standard"/>
+              </a:rPr>
+              <a:t>.</a:t>
+            </a:r>
+            <a:endParaRPr sz="950" b="0" dirty="0">
+              <a:solidFill>
+                <a:srgbClr val="2E3440"/>
+              </a:solidFill>
+              <a:latin typeface="Calibri"/>
+            </a:endParaRPr>
           </a:p>
         </p:txBody>
       </p:sp>
@@ -9665,6 +9782,66 @@
           </a:p>
         </p:txBody>
       </p:sp>
+      <p:pic>
+        <p:nvPicPr>
+          <p:cNvPr id="17" name="Picture 16">
+            <a:extLst>
+              <a:ext uri="{FF2B5EF4-FFF2-40B4-BE49-F238E27FC236}">
+                <a16:creationId xmlns:a16="http://schemas.microsoft.com/office/drawing/2014/main" id="{EE2ADC04-A028-5A48-091A-5BDA103B20C2}"/>
+              </a:ext>
+            </a:extLst>
+          </p:cNvPr>
+          <p:cNvPicPr>
+            <a:picLocks noChangeAspect="1"/>
+          </p:cNvPicPr>
+          <p:nvPr/>
+        </p:nvPicPr>
+        <p:blipFill>
+          <a:blip r:embed="rId2"/>
+          <a:stretch>
+            <a:fillRect/>
+          </a:stretch>
+        </p:blipFill>
+        <p:spPr>
+          <a:xfrm>
+            <a:off x="6834263" y="577583"/>
+            <a:ext cx="4325697" cy="4451617"/>
+          </a:xfrm>
+          <a:prstGeom prst="rect">
+            <a:avLst/>
+          </a:prstGeom>
+        </p:spPr>
+      </p:pic>
+      <p:pic>
+        <p:nvPicPr>
+          <p:cNvPr id="18" name="Picture 17">
+            <a:extLst>
+              <a:ext uri="{FF2B5EF4-FFF2-40B4-BE49-F238E27FC236}">
+                <a16:creationId xmlns:a16="http://schemas.microsoft.com/office/drawing/2014/main" id="{52190386-266A-6406-6C36-E6DA82A1AF8D}"/>
+              </a:ext>
+            </a:extLst>
+          </p:cNvPr>
+          <p:cNvPicPr>
+            <a:picLocks noChangeAspect="1"/>
+          </p:cNvPicPr>
+          <p:nvPr/>
+        </p:nvPicPr>
+        <p:blipFill>
+          <a:blip r:embed="rId3"/>
+          <a:stretch>
+            <a:fillRect/>
+          </a:stretch>
+        </p:blipFill>
+        <p:spPr>
+          <a:xfrm>
+            <a:off x="322262" y="2194055"/>
+            <a:ext cx="6395714" cy="1966297"/>
+          </a:xfrm>
+          <a:prstGeom prst="rect">
+            <a:avLst/>
+          </a:prstGeom>
+        </p:spPr>
+      </p:pic>
     </p:spTree>
   </p:cSld>
   <p:clrMapOvr>
@@ -9729,7 +9906,7 @@
           <a:bodyPr rtlCol="0" anchor="ctr"/>
           <a:lstStyle/>
           <a:p>
-            <a:pPr algn="ctr"/>
+            <a:pPr marL="0" algn="ctr" defTabSz="457200" rtl="1" eaLnBrk="1" latinLnBrk="0" hangingPunct="1"/>
             <a:endParaRPr/>
           </a:p>
         </p:txBody>
@@ -9936,7 +10113,7 @@
         <p:spPr>
           <a:xfrm>
             <a:off x="868680" y="2029968"/>
-            <a:ext cx="1645920" cy="384048"/>
+            <a:ext cx="1645920" cy="261610"/>
           </a:xfrm>
           <a:prstGeom prst="rect">
             <a:avLst/>
@@ -9951,14 +10128,20 @@
           <a:p>
             <a:pPr algn="l"/>
             <a:r>
-              <a:rPr sz="1100" b="1">
+              <a:rPr lang="en-US" sz="1100" b="1" dirty="0">
                 <a:solidFill>
                   <a:srgbClr val="FFFFFF"/>
                 </a:solidFill>
                 <a:latin typeface="Calibri"/>
               </a:rPr>
-              <a:t>Random Forest</a:t>
-            </a:r>
+              <a:t>CNN</a:t>
+            </a:r>
+            <a:endParaRPr sz="1100" b="1" dirty="0">
+              <a:solidFill>
+                <a:srgbClr val="FFFFFF"/>
+              </a:solidFill>
+              <a:latin typeface="Calibri"/>
+            </a:endParaRPr>
           </a:p>
         </p:txBody>
       </p:sp>
@@ -10065,7 +10248,7 @@
           <a:p>
             <a:pPr algn="l"/>
             <a:r>
-              <a:rPr sz="1100" b="1">
+              <a:rPr sz="1100" b="1" dirty="0">
                 <a:solidFill>
                   <a:srgbClr val="FFFFFF"/>
                 </a:solidFill>
@@ -10278,7 +10461,7 @@
         <p:spPr>
           <a:xfrm>
             <a:off x="868680" y="4443984"/>
-            <a:ext cx="1645920" cy="384048"/>
+            <a:ext cx="1645920" cy="261610"/>
           </a:xfrm>
           <a:prstGeom prst="rect">
             <a:avLst/>
@@ -10293,14 +10476,20 @@
           <a:p>
             <a:pPr algn="l"/>
             <a:r>
-              <a:rPr sz="1100" b="1">
+              <a:rPr lang="en-US" sz="1100" b="1" dirty="0">
                 <a:solidFill>
                   <a:srgbClr val="FFFFFF"/>
                 </a:solidFill>
                 <a:latin typeface="Calibri"/>
               </a:rPr>
-              <a:t>BERT (Text)</a:t>
-            </a:r>
+              <a:t>TF – IDF(Text)</a:t>
+            </a:r>
+            <a:endParaRPr sz="1100" b="1" dirty="0">
+              <a:solidFill>
+                <a:srgbClr val="FFFFFF"/>
+              </a:solidFill>
+              <a:latin typeface="Calibri"/>
+            </a:endParaRPr>
           </a:p>
         </p:txBody>
       </p:sp>
@@ -10407,13 +10596,22 @@
           <a:p>
             <a:pPr algn="l"/>
             <a:r>
-              <a:rPr sz="1100" b="1">
+              <a:rPr lang="en-US" sz="1100" b="1" dirty="0">
                 <a:solidFill>
                   <a:srgbClr val="FFFFFF"/>
                 </a:solidFill>
                 <a:latin typeface="Calibri"/>
               </a:rPr>
-              <a:t>Early Fusion</a:t>
+              <a:t>Early</a:t>
+            </a:r>
+            <a:r>
+              <a:rPr sz="1100" b="1" dirty="0">
+                <a:solidFill>
+                  <a:srgbClr val="FFFFFF"/>
+                </a:solidFill>
+                <a:latin typeface="Calibri"/>
+              </a:rPr>
+              <a:t> Fusion</a:t>
             </a:r>
           </a:p>
         </p:txBody>
@@ -10587,7 +10785,7 @@
           <a:bodyPr rtlCol="0" anchor="ctr"/>
           <a:lstStyle/>
           <a:p>
-            <a:pPr algn="ctr"/>
+            <a:pPr marL="0" algn="ctr" defTabSz="457200" rtl="1" eaLnBrk="1" latinLnBrk="0" hangingPunct="1"/>
             <a:endParaRPr/>
           </a:p>
         </p:txBody>
@@ -10737,41 +10935,6 @@
                 <a:latin typeface="Calibri"/>
               </a:rPr>
               <a:t>Random Forest &amp; HuBERT — LOSO evaluation</a:t>
-            </a:r>
-          </a:p>
-        </p:txBody>
-      </p:sp>
-      <p:sp>
-        <p:nvSpPr>
-          <p:cNvPr id="7" name="TextBox 6"/>
-          <p:cNvSpPr txBox="1"/>
-          <p:nvPr/>
-        </p:nvSpPr>
-        <p:spPr>
-          <a:xfrm>
-            <a:off x="777240" y="1874519"/>
-            <a:ext cx="10515600" cy="3017520"/>
-          </a:xfrm>
-          <a:prstGeom prst="rect">
-            <a:avLst/>
-          </a:prstGeom>
-          <a:noFill/>
-        </p:spPr>
-        <p:txBody>
-          <a:bodyPr wrap="square">
-            <a:spAutoFit/>
-          </a:bodyPr>
-          <a:lstStyle/>
-          <a:p>
-            <a:pPr algn="ctr"/>
-            <a:r>
-              <a:rPr sz="1300" b="0">
-                <a:solidFill>
-                  <a:srgbClr val="BBBBBB"/>
-                </a:solidFill>
-                <a:latin typeface="Calibri"/>
-              </a:rPr>
-              <a:t>[INSERT: confusion matrix + per-session UAR bar chart]</a:t>
             </a:r>
           </a:p>
         </p:txBody>
@@ -11026,7 +11189,7 @@
           <a:bodyPr rtlCol="0" anchor="ctr"/>
           <a:lstStyle/>
           <a:p>
-            <a:pPr algn="ctr"/>
+            <a:pPr marL="0" algn="ctr" defTabSz="457200" rtl="1" eaLnBrk="1" latinLnBrk="0" hangingPunct="1"/>
             <a:endParaRPr/>
           </a:p>
         </p:txBody>
@@ -11169,48 +11332,13 @@
           <a:p>
             <a:pPr algn="l"/>
             <a:r>
-              <a:rPr sz="1400" b="1">
+              <a:rPr sz="1400" b="1" dirty="0">
                 <a:solidFill>
                   <a:srgbClr val="4C566A"/>
                 </a:solidFill>
                 <a:latin typeface="Calibri"/>
               </a:rPr>
               <a:t>BERT fine-tuned on transcriptions — LOSO evaluation</a:t>
-            </a:r>
-          </a:p>
-        </p:txBody>
-      </p:sp>
-      <p:sp>
-        <p:nvSpPr>
-          <p:cNvPr id="7" name="TextBox 6"/>
-          <p:cNvSpPr txBox="1"/>
-          <p:nvPr/>
-        </p:nvSpPr>
-        <p:spPr>
-          <a:xfrm>
-            <a:off x="777240" y="1874519"/>
-            <a:ext cx="10515600" cy="3017520"/>
-          </a:xfrm>
-          <a:prstGeom prst="rect">
-            <a:avLst/>
-          </a:prstGeom>
-          <a:noFill/>
-        </p:spPr>
-        <p:txBody>
-          <a:bodyPr wrap="square">
-            <a:spAutoFit/>
-          </a:bodyPr>
-          <a:lstStyle/>
-          <a:p>
-            <a:pPr algn="ctr"/>
-            <a:r>
-              <a:rPr sz="1300" b="0">
-                <a:solidFill>
-                  <a:srgbClr val="BBBBBB"/>
-                </a:solidFill>
-                <a:latin typeface="Calibri"/>
-              </a:rPr>
-              <a:t>[INSERT: classification report table + confusion matrix]</a:t>
             </a:r>
           </a:p>
         </p:txBody>
@@ -11401,6 +11529,66 @@
           </a:p>
         </p:txBody>
       </p:sp>
+      <p:pic>
+        <p:nvPicPr>
+          <p:cNvPr id="15" name="Picture 14" descr="A close-up of words&#10;&#10;AI-generated content may be incorrect.">
+            <a:extLst>
+              <a:ext uri="{FF2B5EF4-FFF2-40B4-BE49-F238E27FC236}">
+                <a16:creationId xmlns:a16="http://schemas.microsoft.com/office/drawing/2014/main" id="{BFC223D2-7753-5691-7CC4-3B5AA7AB20C2}"/>
+              </a:ext>
+            </a:extLst>
+          </p:cNvPr>
+          <p:cNvPicPr>
+            <a:picLocks noChangeAspect="1"/>
+          </p:cNvPicPr>
+          <p:nvPr/>
+        </p:nvPicPr>
+        <p:blipFill>
+          <a:blip r:embed="rId2"/>
+          <a:stretch>
+            <a:fillRect/>
+          </a:stretch>
+        </p:blipFill>
+        <p:spPr>
+          <a:xfrm>
+            <a:off x="777240" y="2032235"/>
+            <a:ext cx="3649662" cy="718502"/>
+          </a:xfrm>
+          <a:prstGeom prst="rect">
+            <a:avLst/>
+          </a:prstGeom>
+        </p:spPr>
+      </p:pic>
+      <p:pic>
+        <p:nvPicPr>
+          <p:cNvPr id="17" name="Picture 16" descr="A diagram of a test confusion matrix&#10;&#10;AI-generated content may be incorrect.">
+            <a:extLst>
+              <a:ext uri="{FF2B5EF4-FFF2-40B4-BE49-F238E27FC236}">
+                <a16:creationId xmlns:a16="http://schemas.microsoft.com/office/drawing/2014/main" id="{7CE8AB8F-2ED4-D325-3C88-AA1BD72EA52D}"/>
+              </a:ext>
+            </a:extLst>
+          </p:cNvPr>
+          <p:cNvPicPr>
+            <a:picLocks noChangeAspect="1"/>
+          </p:cNvPicPr>
+          <p:nvPr/>
+        </p:nvPicPr>
+        <p:blipFill>
+          <a:blip r:embed="rId3"/>
+          <a:stretch>
+            <a:fillRect/>
+          </a:stretch>
+        </p:blipFill>
+        <p:spPr>
+          <a:xfrm>
+            <a:off x="7519584" y="1435271"/>
+            <a:ext cx="4075008" cy="3340833"/>
+          </a:xfrm>
+          <a:prstGeom prst="rect">
+            <a:avLst/>
+          </a:prstGeom>
+        </p:spPr>
+      </p:pic>
     </p:spTree>
   </p:cSld>
   <p:clrMapOvr>

</xml_diff>